<commit_message>
Improve pitch deck and remove PPT generation script
</commit_message>
<xml_diff>
--- a/Uniwise_AI_Presentation.pptx
+++ b/Uniwise_AI_Presentation.pptx
@@ -3213,15 +3213,8 @@
           </a:bodyPr>
           <a:lstStyle/>
           <a:p>
-            <a:pPr>
-              <a:defRPr sz="3600" b="1">
-                <a:solidFill>
-                  <a:srgbClr val="6C63FF"/>
-                </a:solidFill>
-              </a:defRPr>
-            </a:pPr>
-            <a:r>
-              <a:t>Cost Comparison</a:t>
+            <a:r>
+              <a:t>Cost &amp; ROI Snapshot</a:t>
             </a:r>
           </a:p>
         </p:txBody>
@@ -3738,82 +3731,52 @@
         <p:txBody>
           <a:bodyPr/>
           <a:lstStyle/>
-          <a:p/>
-          <a:p>
-            <a:pPr>
-              <a:spcAft>
-                <a:spcPts val="1200"/>
-              </a:spcAft>
+          <a:p>
+            <a:pPr>
               <a:defRPr sz="1800"/>
             </a:pPr>
             <a:r>
-              <a:t>✅ Full RAG implementation complete</a:t>
-            </a:r>
-          </a:p>
-          <a:p>
-            <a:pPr>
-              <a:spcAft>
-                <a:spcPts val="1200"/>
-              </a:spcAft>
+              <a:t>Working end-to-end platform is complete and presentation-ready</a:t>
+            </a:r>
+          </a:p>
+          <a:p>
+            <a:pPr>
               <a:defRPr sz="1800"/>
             </a:pPr>
             <a:r>
-              <a:t>✅ Document upload and processing working</a:t>
-            </a:r>
-          </a:p>
-          <a:p>
-            <a:pPr>
-              <a:spcAft>
-                <a:spcPts val="1200"/>
-              </a:spcAft>
+              <a:t>RAG Q&amp;A, flashcards, and quizzes operate in one integrated workflow</a:t>
+            </a:r>
+          </a:p>
+          <a:p>
+            <a:pPr>
               <a:defRPr sz="1800"/>
             </a:pPr>
             <a:r>
-              <a:t>✅ AI Q&amp;A, flashcards, quizzes functional</a:t>
-            </a:r>
-          </a:p>
-          <a:p>
-            <a:pPr>
-              <a:spcAft>
-                <a:spcPts val="1200"/>
-              </a:spcAft>
+              <a:t>Evidence-backed answer format aligns with faculty expectations</a:t>
+            </a:r>
+          </a:p>
+          <a:p>
+            <a:pPr>
               <a:defRPr sz="1800"/>
             </a:pPr>
             <a:r>
-              <a:t>✅ Progress tracking and analytics</a:t>
-            </a:r>
-          </a:p>
-          <a:p>
-            <a:pPr>
-              <a:spcAft>
-                <a:spcPts val="1200"/>
-              </a:spcAft>
+              <a:t>Pilot-ready for 1-2 courses with clear success metrics</a:t>
+            </a:r>
+          </a:p>
+          <a:p>
+            <a:pPr>
               <a:defRPr sz="1800"/>
             </a:pPr>
             <a:r>
-              <a:t>✅ Docker deployment ready</a:t>
-            </a:r>
-          </a:p>
-          <a:p>
-            <a:pPr>
-              <a:spcAft>
-                <a:spcPts val="1200"/>
-              </a:spcAft>
+              <a:t>Suggested KPIs: trust score, usage, retention, and faculty time saved</a:t>
+            </a:r>
+          </a:p>
+          <a:p>
+            <a:pPr>
               <a:defRPr sz="1800"/>
             </a:pPr>
             <a:r>
-              <a:t>✅ Web interface live</a:t>
-            </a:r>
-          </a:p>
-          <a:p>
-            <a:pPr>
-              <a:spcAft>
-                <a:spcPts val="1200"/>
-              </a:spcAft>
-              <a:defRPr sz="1800"/>
-            </a:pPr>
-            <a:r>
-              <a:t>🎯 Ready for pilot with 50-100 students</a:t>
+              <a:t>Scalable path from pilot to department and campus rollout</a:t>
             </a:r>
           </a:p>
         </p:txBody>
@@ -3972,71 +3935,44 @@
         <p:txBody>
           <a:bodyPr/>
           <a:lstStyle/>
-          <a:p/>
-          <a:p>
-            <a:pPr>
-              <a:spcAft>
-                <a:spcPts val="1200"/>
-              </a:spcAft>
+          <a:p>
+            <a:pPr>
               <a:defRPr sz="1800"/>
             </a:pPr>
             <a:r>
-              <a:t>1. Pilot program with 1-2 courses (50-100 students)</a:t>
-            </a:r>
-          </a:p>
-          <a:p>
-            <a:pPr>
-              <a:spcAft>
-                <a:spcPts val="1200"/>
-              </a:spcAft>
+              <a:t>Launch pilot with 50-100 students across 1-2 courses</a:t>
+            </a:r>
+          </a:p>
+          <a:p>
+            <a:pPr>
               <a:defRPr sz="1800"/>
             </a:pPr>
             <a:r>
-              <a:t>2. Gather feedback and analytics</a:t>
-            </a:r>
-          </a:p>
-          <a:p>
-            <a:pPr>
-              <a:spcAft>
-                <a:spcPts val="1200"/>
-              </a:spcAft>
+              <a:t>Measure baseline vs post-pilot on outcomes and engagement</a:t>
+            </a:r>
+          </a:p>
+          <a:p>
+            <a:pPr>
               <a:defRPr sz="1800"/>
             </a:pPr>
             <a:r>
-              <a:t>3. Expand to more courses based on success</a:t>
-            </a:r>
-          </a:p>
-          <a:p>
-            <a:pPr>
-              <a:spcAft>
-                <a:spcPts val="1200"/>
-              </a:spcAft>
+              <a:t>Run weekly faculty feedback loop for rapid improvement</a:t>
+            </a:r>
+          </a:p>
+          <a:p>
+            <a:pPr>
               <a:defRPr sz="1800"/>
             </a:pPr>
             <a:r>
-              <a:t>4. University-wide rollout</a:t>
-            </a:r>
-          </a:p>
-          <a:p>
-            <a:pPr>
-              <a:spcAft>
-                <a:spcPts val="1200"/>
-              </a:spcAft>
+              <a:t>Finalize governance checklist for institutional approval</a:t>
+            </a:r>
+          </a:p>
+          <a:p>
+            <a:pPr>
               <a:defRPr sz="1800"/>
             </a:pPr>
             <a:r>
-              <a:t>5. Integration with existing LMS (Canvas, Blackboard)</a:t>
-            </a:r>
-          </a:p>
-          <a:p>
-            <a:pPr>
-              <a:spcAft>
-                <a:spcPts val="1200"/>
-              </a:spcAft>
-              <a:defRPr sz="1800"/>
-            </a:pPr>
-            <a:r>
-              <a:t>6. Scale to multiple universities</a:t>
+              <a:t>Scale to department rollout after pilot validation</a:t>
             </a:r>
           </a:p>
         </p:txBody>
@@ -4200,60 +4136,44 @@
         <p:txBody>
           <a:bodyPr/>
           <a:lstStyle/>
-          <a:p/>
-          <a:p>
-            <a:pPr>
-              <a:spcAft>
-                <a:spcPts val="1200"/>
-              </a:spcAft>
+          <a:p>
+            <a:pPr>
               <a:defRPr sz="1800"/>
             </a:pPr>
             <a:r>
-              <a:t>Students use ChatGPT for homework — but it gives generic answers</a:t>
-            </a:r>
-          </a:p>
-          <a:p>
-            <a:pPr>
-              <a:spcAft>
-                <a:spcPts val="1200"/>
-              </a:spcAft>
+              <a:t>Students already use AI, but answers are often generic and unverifiable</a:t>
+            </a:r>
+          </a:p>
+          <a:p>
+            <a:pPr>
               <a:defRPr sz="1800"/>
             </a:pPr>
             <a:r>
-              <a:t>Generic AI tools hallucinate facts not in your curriculum</a:t>
-            </a:r>
-          </a:p>
-          <a:p>
-            <a:pPr>
-              <a:spcAft>
-                <a:spcPts val="1200"/>
-              </a:spcAft>
+              <a:t>Faculty trust drops when responses are not tied to course material</a:t>
+            </a:r>
+          </a:p>
+          <a:p>
+            <a:pPr>
               <a:defRPr sz="1800"/>
             </a:pPr>
             <a:r>
-              <a:t>No way to verify if answers come from course materials</a:t>
-            </a:r>
-          </a:p>
-          <a:p>
-            <a:pPr>
-              <a:spcAft>
-                <a:spcPts val="1200"/>
-              </a:spcAft>
+              <a:t>Academic integrity risk increases without source-backed answers</a:t>
+            </a:r>
+          </a:p>
+          <a:p>
+            <a:pPr>
               <a:defRPr sz="1800"/>
             </a:pPr>
             <a:r>
-              <a:t>Promotes academic dishonesty</a:t>
-            </a:r>
-          </a:p>
-          <a:p>
-            <a:pPr>
-              <a:spcAft>
-                <a:spcPts val="1200"/>
-              </a:spcAft>
+              <a:t>Faculty workload rises because students still need manual clarification</a:t>
+            </a:r>
+          </a:p>
+          <a:p>
+            <a:pPr>
               <a:defRPr sz="1800"/>
             </a:pPr>
             <a:r>
-              <a:t>Students struggle to retain information from passive reading</a:t>
+              <a:t>Institutions need AI that improves outcomes, not just speed</a:t>
             </a:r>
           </a:p>
         </p:txBody>
@@ -4318,71 +4238,52 @@
         <p:txBody>
           <a:bodyPr/>
           <a:lstStyle/>
-          <a:p/>
-          <a:p>
-            <a:pPr>
-              <a:spcAft>
-                <a:spcPts val="1200"/>
-              </a:spcAft>
+          <a:p>
+            <a:pPr>
               <a:defRPr sz="1800"/>
             </a:pPr>
             <a:r>
-              <a:t>AI that ONLY answers from professor-uploaded documents</a:t>
-            </a:r>
-          </a:p>
-          <a:p>
-            <a:pPr>
-              <a:spcAft>
-                <a:spcPts val="1200"/>
-              </a:spcAft>
+              <a:t>Course-aligned AI tutor grounded in faculty-uploaded materials</a:t>
+            </a:r>
+          </a:p>
+          <a:p>
+            <a:pPr>
               <a:defRPr sz="1800"/>
             </a:pPr>
             <a:r>
-              <a:t>RAG (Retrieval Augmented Generation) prevents hallucinations</a:t>
-            </a:r>
-          </a:p>
-          <a:p>
-            <a:pPr>
-              <a:spcAft>
-                <a:spcPts val="1200"/>
-              </a:spcAft>
+              <a:t>RAG retrieves relevant passages before any answer is generated</a:t>
+            </a:r>
+          </a:p>
+          <a:p>
+            <a:pPr>
               <a:defRPr sz="1800"/>
             </a:pPr>
             <a:r>
-              <a:t>Every answer includes source citations</a:t>
-            </a:r>
-          </a:p>
-          <a:p>
-            <a:pPr>
-              <a:spcAft>
-                <a:spcPts val="1200"/>
-              </a:spcAft>
+              <a:t>Every response includes sources that faculty can verify quickly</a:t>
+            </a:r>
+          </a:p>
+          <a:p>
+            <a:pPr>
               <a:defRPr sz="1800"/>
             </a:pPr>
             <a:r>
-              <a:t>Automatic flashcards &amp; quizzes from your content</a:t>
-            </a:r>
-          </a:p>
-          <a:p>
-            <a:pPr>
-              <a:spcAft>
-                <a:spcPts val="1200"/>
-              </a:spcAft>
+              <a:t>Flashcards and quizzes are auto-generated from approved content</a:t>
+            </a:r>
+          </a:p>
+          <a:p>
+            <a:pPr>
               <a:defRPr sz="1800"/>
             </a:pPr>
             <a:r>
-              <a:t>Progress tracking and spaced repetition learning</a:t>
-            </a:r>
-          </a:p>
-          <a:p>
-            <a:pPr>
-              <a:spcAft>
-                <a:spcPts val="1200"/>
-              </a:spcAft>
+              <a:t>University-level data isolation supports governance and privacy</a:t>
+            </a:r>
+          </a:p>
+          <a:p>
+            <a:pPr>
               <a:defRPr sz="1800"/>
             </a:pPr>
             <a:r>
-              <a:t>University data isolation — 100% privacy</a:t>
+              <a:t>Affordable, local-first architecture for campus-scale deployment</a:t>
             </a:r>
           </a:p>
         </p:txBody>
@@ -4413,7 +4314,7 @@
         </p:nvSpPr>
         <p:spPr>
           <a:xfrm>
-            <a:off x="457200" y="457200"/>
+            <a:off x="457200" y="365760"/>
             <a:ext cx="8229600" cy="731520"/>
           </a:xfrm>
           <a:prstGeom prst="rect">
@@ -4427,15 +4328,8 @@
           </a:bodyPr>
           <a:lstStyle/>
           <a:p>
-            <a:pPr>
-              <a:defRPr sz="3600" b="1">
-                <a:solidFill>
-                  <a:srgbClr val="6C63FF"/>
-                </a:solidFill>
-              </a:defRPr>
-            </a:pPr>
-            <a:r>
-              <a:t>What is RAG?</a:t>
+            <a:r>
+              <a:t>How Uniwise RAG Works</a:t>
             </a:r>
           </a:p>
         </p:txBody>
@@ -4448,8 +4342,8 @@
         </p:nvSpPr>
         <p:spPr>
           <a:xfrm>
-            <a:off x="914400" y="1371600"/>
-            <a:ext cx="7315200" cy="4572000"/>
+            <a:off x="640080" y="1188720"/>
+            <a:ext cx="7863840" cy="457200"/>
           </a:xfrm>
           <a:prstGeom prst="rect">
             <a:avLst/>
@@ -4457,86 +4351,229 @@
           <a:noFill/>
         </p:spPr>
         <p:txBody>
+          <a:bodyPr wrap="none">
+            <a:spAutoFit/>
+          </a:bodyPr>
+          <a:lstStyle/>
+          <a:p>
+            <a:r>
+              <a:t>1) Faculty Upload Content</a:t>
+            </a:r>
+          </a:p>
+        </p:txBody>
+      </p:sp>
+      <p:sp>
+        <p:nvSpPr>
+          <p:cNvPr id="4" name="TextBox 3"/>
+          <p:cNvSpPr txBox="1"/>
+          <p:nvPr/>
+        </p:nvSpPr>
+        <p:spPr>
+          <a:xfrm>
+            <a:off x="868680" y="1600200"/>
+            <a:ext cx="7498079" cy="548640"/>
+          </a:xfrm>
+          <a:prstGeom prst="rect">
+            <a:avLst/>
+          </a:prstGeom>
+          <a:noFill/>
+        </p:spPr>
+        <p:txBody>
           <a:bodyPr wrap="square">
             <a:spAutoFit/>
           </a:bodyPr>
           <a:lstStyle/>
-          <a:p/>
-          <a:p>
-            <a:pPr>
-              <a:spcAft>
-                <a:spcPts val="1400"/>
-              </a:spcAft>
-              <a:defRPr sz="1600"/>
-            </a:pPr>
-            <a:r>
-              <a:t>1. Professor uploads course documents (PDF, DOCX, TXT)</a:t>
-            </a:r>
-          </a:p>
-          <a:p>
-            <a:pPr>
-              <a:spcAft>
-                <a:spcPts val="1400"/>
-              </a:spcAft>
-              <a:defRPr sz="1600"/>
-            </a:pPr>
-            <a:r>
-              <a:t>2. System extracts text and creates searchable 'embeddings'</a:t>
-            </a:r>
-          </a:p>
-          <a:p>
-            <a:pPr>
-              <a:spcAft>
-                <a:spcPts val="1400"/>
-              </a:spcAft>
-              <a:defRPr sz="1600"/>
-            </a:pPr>
-            <a:r>
-              <a:t>3. Student asks: 'What is photosynthesis?'</a:t>
-            </a:r>
-          </a:p>
-          <a:p>
-            <a:pPr>
-              <a:spcAft>
-                <a:spcPts val="1400"/>
-              </a:spcAft>
-              <a:defRPr sz="1600"/>
-            </a:pPr>
-            <a:r>
-              <a:t>4. System searches YOUR documents for relevant paragraphs</a:t>
-            </a:r>
-          </a:p>
-          <a:p>
-            <a:pPr>
-              <a:spcAft>
-                <a:spcPts val="1400"/>
-              </a:spcAft>
-              <a:defRPr sz="1600"/>
-            </a:pPr>
-            <a:r>
-              <a:t>5. AI receives ONLY those paragraphs as context</a:t>
-            </a:r>
-          </a:p>
-          <a:p>
-            <a:pPr>
-              <a:spcAft>
-                <a:spcPts val="1400"/>
-              </a:spcAft>
-              <a:defRPr sz="1600"/>
-            </a:pPr>
-            <a:r>
-              <a:t>6. AI generates answer using ONLY provided context</a:t>
-            </a:r>
-          </a:p>
-          <a:p>
-            <a:pPr>
-              <a:spcAft>
-                <a:spcPts val="1400"/>
-              </a:spcAft>
-              <a:defRPr sz="1600"/>
-            </a:pPr>
-            <a:r>
-              <a:t>7. Answer returned with source citations</a:t>
+          <a:p>
+            <a:r>
+              <a:t>• Course documents are validated, extracted, and chunked</a:t>
+            </a:r>
+          </a:p>
+          <a:p>
+            <a:r>
+              <a:t>• Chunks are embedded and indexed for semantic retrieval</a:t>
+            </a:r>
+          </a:p>
+        </p:txBody>
+      </p:sp>
+      <p:sp>
+        <p:nvSpPr>
+          <p:cNvPr id="5" name="TextBox 4"/>
+          <p:cNvSpPr txBox="1"/>
+          <p:nvPr/>
+        </p:nvSpPr>
+        <p:spPr>
+          <a:xfrm>
+            <a:off x="640080" y="2441448"/>
+            <a:ext cx="7863840" cy="457200"/>
+          </a:xfrm>
+          <a:prstGeom prst="rect">
+            <a:avLst/>
+          </a:prstGeom>
+          <a:noFill/>
+        </p:spPr>
+        <p:txBody>
+          <a:bodyPr wrap="none">
+            <a:spAutoFit/>
+          </a:bodyPr>
+          <a:lstStyle/>
+          <a:p>
+            <a:r>
+              <a:t>2) Student Asks a Question</a:t>
+            </a:r>
+          </a:p>
+        </p:txBody>
+      </p:sp>
+      <p:sp>
+        <p:nvSpPr>
+          <p:cNvPr id="6" name="TextBox 5"/>
+          <p:cNvSpPr txBox="1"/>
+          <p:nvPr/>
+        </p:nvSpPr>
+        <p:spPr>
+          <a:xfrm>
+            <a:off x="868680" y="2852928"/>
+            <a:ext cx="7498079" cy="548640"/>
+          </a:xfrm>
+          <a:prstGeom prst="rect">
+            <a:avLst/>
+          </a:prstGeom>
+          <a:noFill/>
+        </p:spPr>
+        <p:txBody>
+          <a:bodyPr wrap="square">
+            <a:spAutoFit/>
+          </a:bodyPr>
+          <a:lstStyle/>
+          <a:p>
+            <a:r>
+              <a:t>• System searches only the university/course collection</a:t>
+            </a:r>
+          </a:p>
+          <a:p>
+            <a:r>
+              <a:t>• Low-relevance chunks are filtered before generation</a:t>
+            </a:r>
+          </a:p>
+        </p:txBody>
+      </p:sp>
+      <p:sp>
+        <p:nvSpPr>
+          <p:cNvPr id="7" name="TextBox 6"/>
+          <p:cNvSpPr txBox="1"/>
+          <p:nvPr/>
+        </p:nvSpPr>
+        <p:spPr>
+          <a:xfrm>
+            <a:off x="640080" y="3694176"/>
+            <a:ext cx="7863840" cy="457200"/>
+          </a:xfrm>
+          <a:prstGeom prst="rect">
+            <a:avLst/>
+          </a:prstGeom>
+          <a:noFill/>
+        </p:spPr>
+        <p:txBody>
+          <a:bodyPr wrap="none">
+            <a:spAutoFit/>
+          </a:bodyPr>
+          <a:lstStyle/>
+          <a:p>
+            <a:r>
+              <a:t>3) AI Generates a Grounded Response</a:t>
+            </a:r>
+          </a:p>
+        </p:txBody>
+      </p:sp>
+      <p:sp>
+        <p:nvSpPr>
+          <p:cNvPr id="8" name="TextBox 7"/>
+          <p:cNvSpPr txBox="1"/>
+          <p:nvPr/>
+        </p:nvSpPr>
+        <p:spPr>
+          <a:xfrm>
+            <a:off x="868680" y="4105656"/>
+            <a:ext cx="7498079" cy="822959"/>
+          </a:xfrm>
+          <a:prstGeom prst="rect">
+            <a:avLst/>
+          </a:prstGeom>
+          <a:noFill/>
+        </p:spPr>
+        <p:txBody>
+          <a:bodyPr wrap="square">
+            <a:spAutoFit/>
+          </a:bodyPr>
+          <a:lstStyle/>
+          <a:p>
+            <a:r>
+              <a:t>• Model receives retrieved evidence only</a:t>
+            </a:r>
+          </a:p>
+          <a:p>
+            <a:r>
+              <a:t>• Answer is returned with source citations</a:t>
+            </a:r>
+          </a:p>
+        </p:txBody>
+      </p:sp>
+      <p:sp>
+        <p:nvSpPr>
+          <p:cNvPr id="9" name="TextBox 8"/>
+          <p:cNvSpPr txBox="1"/>
+          <p:nvPr/>
+        </p:nvSpPr>
+        <p:spPr>
+          <a:xfrm>
+            <a:off x="640080" y="5239512"/>
+            <a:ext cx="7863840" cy="457200"/>
+          </a:xfrm>
+          <a:prstGeom prst="rect">
+            <a:avLst/>
+          </a:prstGeom>
+          <a:noFill/>
+        </p:spPr>
+        <p:txBody>
+          <a:bodyPr wrap="none">
+            <a:spAutoFit/>
+          </a:bodyPr>
+          <a:lstStyle/>
+          <a:p>
+            <a:r>
+              <a:t>4) Trust &amp; Control Layer</a:t>
+            </a:r>
+          </a:p>
+        </p:txBody>
+      </p:sp>
+      <p:sp>
+        <p:nvSpPr>
+          <p:cNvPr id="10" name="TextBox 9"/>
+          <p:cNvSpPr txBox="1"/>
+          <p:nvPr/>
+        </p:nvSpPr>
+        <p:spPr>
+          <a:xfrm>
+            <a:off x="868680" y="5650992"/>
+            <a:ext cx="7498079" cy="548640"/>
+          </a:xfrm>
+          <a:prstGeom prst="rect">
+            <a:avLst/>
+          </a:prstGeom>
+          <a:noFill/>
+        </p:spPr>
+        <p:txBody>
+          <a:bodyPr wrap="square">
+            <a:spAutoFit/>
+          </a:bodyPr>
+          <a:lstStyle/>
+          <a:p>
+            <a:r>
+              <a:t>• Tenant isolation protects institutional boundaries</a:t>
+            </a:r>
+          </a:p>
+          <a:p>
+            <a:r>
+              <a:t>• If evidence is missing, system says so transparently</a:t>
             </a:r>
           </a:p>
         </p:txBody>
@@ -4710,15 +4747,8 @@
           </a:bodyPr>
           <a:lstStyle/>
           <a:p>
-            <a:pPr>
-              <a:defRPr sz="3600" b="1">
-                <a:solidFill>
-                  <a:srgbClr val="6C63FF"/>
-                </a:solidFill>
-              </a:defRPr>
-            </a:pPr>
-            <a:r>
-              <a:t>RAG vs Generic AI</a:t>
+            <a:r>
+              <a:t>Why Faculty Can Trust Uniwise</a:t>
             </a:r>
           </a:p>
         </p:txBody>
@@ -4744,72 +4774,34 @@
             <a:spAutoFit/>
           </a:bodyPr>
           <a:lstStyle/>
-          <a:p/>
-          <a:p>
-            <a:pPr>
-              <a:defRPr sz="2000" b="1">
-                <a:solidFill>
-                  <a:srgbClr val="43E97B"/>
-                </a:solidFill>
-              </a:defRPr>
-            </a:pPr>
-            <a:r>
-              <a:t>❌ Generic AI (ChatGPT)</a:t>
-            </a:r>
-          </a:p>
-          <a:p>
-            <a:pPr>
-              <a:spcAft>
-                <a:spcPts val="800"/>
-              </a:spcAft>
-              <a:defRPr sz="1400"/>
-            </a:pPr>
-            <a:r>
-              <a:t>• Uses general knowledge from training</a:t>
-            </a:r>
-          </a:p>
-          <a:p>
-            <a:pPr>
-              <a:spcAft>
-                <a:spcPts val="800"/>
-              </a:spcAft>
-              <a:defRPr sz="1400"/>
-            </a:pPr>
-            <a:r>
-              <a:t>• May provide outdated information</a:t>
-            </a:r>
-          </a:p>
-          <a:p>
-            <a:pPr>
-              <a:spcAft>
-                <a:spcPts val="800"/>
-              </a:spcAft>
-              <a:defRPr sz="1400"/>
-            </a:pPr>
-            <a:r>
-              <a:t>• No source verification</a:t>
-            </a:r>
-          </a:p>
-          <a:p>
-            <a:pPr>
-              <a:spcAft>
-                <a:spcPts val="800"/>
-              </a:spcAft>
-              <a:defRPr sz="1400"/>
-            </a:pPr>
-            <a:r>
-              <a:t>• Can make up facts</a:t>
-            </a:r>
-          </a:p>
-          <a:p>
-            <a:pPr>
-              <a:spcAft>
-                <a:spcPts val="800"/>
-              </a:spcAft>
-              <a:defRPr sz="1400"/>
-            </a:pPr>
-            <a:r>
-              <a:t>• Not curriculum-specific</a:t>
+          <a:p>
+            <a:r>
+              <a:t>❌ Generic AI Tools</a:t>
+            </a:r>
+          </a:p>
+          <a:p>
+            <a:r>
+              <a:t>• Broad, non-syllabus responses</a:t>
+            </a:r>
+          </a:p>
+          <a:p>
+            <a:r>
+              <a:t>• Hard to verify in grading context</a:t>
+            </a:r>
+          </a:p>
+          <a:p>
+            <a:r>
+              <a:t>• Higher hallucination risk</a:t>
+            </a:r>
+          </a:p>
+          <a:p>
+            <a:r>
+              <a:t>• Limited institutional control</a:t>
+            </a:r>
+          </a:p>
+          <a:p>
+            <a:r>
+              <a:t>• Weak audit trail</a:t>
             </a:r>
           </a:p>
         </p:txBody>
@@ -4835,72 +4827,34 @@
             <a:spAutoFit/>
           </a:bodyPr>
           <a:lstStyle/>
-          <a:p/>
-          <a:p>
-            <a:pPr>
-              <a:defRPr sz="2000" b="1">
-                <a:solidFill>
-                  <a:srgbClr val="FF6584"/>
-                </a:solidFill>
-              </a:defRPr>
-            </a:pPr>
-            <a:r>
-              <a:t>✅ Uniwise AI (RAG)</a:t>
-            </a:r>
-          </a:p>
-          <a:p>
-            <a:pPr>
-              <a:spcAft>
-                <a:spcPts val="800"/>
-              </a:spcAft>
-              <a:defRPr sz="1400"/>
-            </a:pPr>
-            <a:r>
-              <a:t>• Only uses YOUR uploaded documents</a:t>
-            </a:r>
-          </a:p>
-          <a:p>
-            <a:pPr>
-              <a:spcAft>
-                <a:spcPts val="800"/>
-              </a:spcAft>
-              <a:defRPr sz="1400"/>
-            </a:pPr>
-            <a:r>
-              <a:t>• Always up-to-date with your content</a:t>
-            </a:r>
-          </a:p>
-          <a:p>
-            <a:pPr>
-              <a:spcAft>
-                <a:spcPts val="800"/>
-              </a:spcAft>
-              <a:defRPr sz="1400"/>
-            </a:pPr>
-            <a:r>
-              <a:t>• Every answer cites source document</a:t>
-            </a:r>
-          </a:p>
-          <a:p>
-            <a:pPr>
-              <a:spcAft>
-                <a:spcPts val="800"/>
-              </a:spcAft>
-              <a:defRPr sz="1400"/>
-            </a:pPr>
-            <a:r>
-              <a:t>• Cannot make up facts</a:t>
-            </a:r>
-          </a:p>
-          <a:p>
-            <a:pPr>
-              <a:spcAft>
-                <a:spcPts val="800"/>
-              </a:spcAft>
-              <a:defRPr sz="1400"/>
-            </a:pPr>
-            <a:r>
-              <a:t>• 100% curriculum-aligned</a:t>
+          <a:p>
+            <a:r>
+              <a:t>✅ Uniwise AI</a:t>
+            </a:r>
+          </a:p>
+          <a:p>
+            <a:r>
+              <a:t>• Syllabus-grounded retrieval before answering</a:t>
+            </a:r>
+          </a:p>
+          <a:p>
+            <a:r>
+              <a:t>• Source citations for verification</a:t>
+            </a:r>
+          </a:p>
+          <a:p>
+            <a:r>
+              <a:t>• Constrained generation from course evidence</a:t>
+            </a:r>
+          </a:p>
+          <a:p>
+            <a:r>
+              <a:t>• University-owned data boundaries</a:t>
+            </a:r>
+          </a:p>
+          <a:p>
+            <a:r>
+              <a:t>• Clear accountability for academic use</a:t>
             </a:r>
           </a:p>
         </p:txBody>
@@ -4931,7 +4885,7 @@
         </p:nvSpPr>
         <p:spPr>
           <a:xfrm>
-            <a:off x="457200" y="457200"/>
+            <a:off x="457200" y="365760"/>
             <a:ext cx="8229600" cy="731520"/>
           </a:xfrm>
           <a:prstGeom prst="rect">
@@ -4945,15 +4899,8 @@
           </a:bodyPr>
           <a:lstStyle/>
           <a:p>
-            <a:pPr>
-              <a:defRPr sz="3600" b="1">
-                <a:solidFill>
-                  <a:srgbClr val="6C63FF"/>
-                </a:solidFill>
-              </a:defRPr>
-            </a:pPr>
-            <a:r>
-              <a:t>System Architecture</a:t>
+            <a:r>
+              <a:t>Technical Reliability (Judge View)</a:t>
             </a:r>
           </a:p>
         </p:txBody>
@@ -4966,8 +4913,8 @@
         </p:nvSpPr>
         <p:spPr>
           <a:xfrm>
-            <a:off x="1371600" y="1645920"/>
-            <a:ext cx="6400800" cy="4114800"/>
+            <a:off x="640080" y="1188720"/>
+            <a:ext cx="7863840" cy="457200"/>
           </a:xfrm>
           <a:prstGeom prst="rect">
             <a:avLst/>
@@ -4975,60 +4922,219 @@
           <a:noFill/>
         </p:spPr>
         <p:txBody>
+          <a:bodyPr wrap="none">
+            <a:spAutoFit/>
+          </a:bodyPr>
+          <a:lstStyle/>
+          <a:p>
+            <a:r>
+              <a:t>Access Control</a:t>
+            </a:r>
+          </a:p>
+        </p:txBody>
+      </p:sp>
+      <p:sp>
+        <p:nvSpPr>
+          <p:cNvPr id="4" name="TextBox 3"/>
+          <p:cNvSpPr txBox="1"/>
+          <p:nvPr/>
+        </p:nvSpPr>
+        <p:spPr>
+          <a:xfrm>
+            <a:off x="868680" y="1600200"/>
+            <a:ext cx="7498079" cy="548640"/>
+          </a:xfrm>
+          <a:prstGeom prst="rect">
+            <a:avLst/>
+          </a:prstGeom>
+          <a:noFill/>
+        </p:spPr>
+        <p:txBody>
           <a:bodyPr wrap="square">
             <a:spAutoFit/>
           </a:bodyPr>
           <a:lstStyle/>
-          <a:p/>
-          <a:p>
-            <a:pPr>
-              <a:defRPr sz="1600">
-                <a:latin typeface="Courier New"/>
-              </a:defRPr>
-            </a:pPr>
-            <a:r>
-              <a:t>React Frontend (Student Interface)</a:t>
-            </a:r>
-            <a:br/>
-            <a:r>
-              <a:t>        ↓</a:t>
-            </a:r>
-            <a:br/>
-            <a:r>
-              <a:t>Django Backend (Python)</a:t>
-            </a:r>
-            <a:br/>
-            <a:r>
-              <a:t>        ↓</a:t>
-            </a:r>
-            <a:br/>
-            <a:r>
-              <a:t>┌───────────┬───────────┬───────────┐</a:t>
-            </a:r>
-            <a:br/>
-            <a:r>
-              <a:t>│           │           │           │</a:t>
-            </a:r>
-            <a:br/>
-            <a:r>
-              <a:t>PostgreSQL  ChromaDB   Ollama AI</a:t>
-            </a:r>
-            <a:br/>
-            <a:r>
-              <a:t>(Database)  (Vectors)  (llama3.2)</a:t>
-            </a:r>
-            <a:br/>
-            <a:br/>
-            <a:r>
-              <a:t>- PostgreSQL: User data, quizzes, progress</a:t>
-            </a:r>
-            <a:br/>
-            <a:r>
-              <a:t>- ChromaDB: Document embeddings (RAG)</a:t>
-            </a:r>
-            <a:br/>
-            <a:r>
-              <a:t>- Ollama: Local AI (no cloud, no costs)</a:t>
+          <a:p>
+            <a:r>
+              <a:t>• Only authenticated university users can query their institution corpus</a:t>
+            </a:r>
+          </a:p>
+        </p:txBody>
+      </p:sp>
+      <p:sp>
+        <p:nvSpPr>
+          <p:cNvPr id="5" name="TextBox 4"/>
+          <p:cNvSpPr txBox="1"/>
+          <p:nvPr/>
+        </p:nvSpPr>
+        <p:spPr>
+          <a:xfrm>
+            <a:off x="640080" y="2441448"/>
+            <a:ext cx="7863840" cy="457200"/>
+          </a:xfrm>
+          <a:prstGeom prst="rect">
+            <a:avLst/>
+          </a:prstGeom>
+          <a:noFill/>
+        </p:spPr>
+        <p:txBody>
+          <a:bodyPr wrap="none">
+            <a:spAutoFit/>
+          </a:bodyPr>
+          <a:lstStyle/>
+          <a:p>
+            <a:r>
+              <a:t>Retrieval Quality</a:t>
+            </a:r>
+          </a:p>
+        </p:txBody>
+      </p:sp>
+      <p:sp>
+        <p:nvSpPr>
+          <p:cNvPr id="6" name="TextBox 5"/>
+          <p:cNvSpPr txBox="1"/>
+          <p:nvPr/>
+        </p:nvSpPr>
+        <p:spPr>
+          <a:xfrm>
+            <a:off x="868680" y="2852928"/>
+            <a:ext cx="7498079" cy="822959"/>
+          </a:xfrm>
+          <a:prstGeom prst="rect">
+            <a:avLst/>
+          </a:prstGeom>
+          <a:noFill/>
+        </p:spPr>
+        <p:txBody>
+          <a:bodyPr wrap="square">
+            <a:spAutoFit/>
+          </a:bodyPr>
+          <a:lstStyle/>
+          <a:p>
+            <a:r>
+              <a:t>• ChromaDB returns top semantic matches</a:t>
+            </a:r>
+          </a:p>
+          <a:p>
+            <a:r>
+              <a:t>• Distance threshold removes weak evidence</a:t>
+            </a:r>
+          </a:p>
+        </p:txBody>
+      </p:sp>
+      <p:sp>
+        <p:nvSpPr>
+          <p:cNvPr id="7" name="TextBox 6"/>
+          <p:cNvSpPr txBox="1"/>
+          <p:nvPr/>
+        </p:nvSpPr>
+        <p:spPr>
+          <a:xfrm>
+            <a:off x="640080" y="3986784"/>
+            <a:ext cx="7863840" cy="457200"/>
+          </a:xfrm>
+          <a:prstGeom prst="rect">
+            <a:avLst/>
+          </a:prstGeom>
+          <a:noFill/>
+        </p:spPr>
+        <p:txBody>
+          <a:bodyPr wrap="none">
+            <a:spAutoFit/>
+          </a:bodyPr>
+          <a:lstStyle/>
+          <a:p>
+            <a:r>
+              <a:t>Grounded Generation</a:t>
+            </a:r>
+          </a:p>
+        </p:txBody>
+      </p:sp>
+      <p:sp>
+        <p:nvSpPr>
+          <p:cNvPr id="8" name="TextBox 7"/>
+          <p:cNvSpPr txBox="1"/>
+          <p:nvPr/>
+        </p:nvSpPr>
+        <p:spPr>
+          <a:xfrm>
+            <a:off x="868680" y="4398264"/>
+            <a:ext cx="7498079" cy="548640"/>
+          </a:xfrm>
+          <a:prstGeom prst="rect">
+            <a:avLst/>
+          </a:prstGeom>
+          <a:noFill/>
+        </p:spPr>
+        <p:txBody>
+          <a:bodyPr wrap="square">
+            <a:spAutoFit/>
+          </a:bodyPr>
+          <a:lstStyle/>
+          <a:p>
+            <a:r>
+              <a:t>• Prompt policy blocks external knowledge</a:t>
+            </a:r>
+          </a:p>
+          <a:p>
+            <a:r>
+              <a:t>• Sources are attached to each answer</a:t>
+            </a:r>
+          </a:p>
+        </p:txBody>
+      </p:sp>
+      <p:sp>
+        <p:nvSpPr>
+          <p:cNvPr id="9" name="TextBox 8"/>
+          <p:cNvSpPr txBox="1"/>
+          <p:nvPr/>
+        </p:nvSpPr>
+        <p:spPr>
+          <a:xfrm>
+            <a:off x="640080" y="5239512"/>
+            <a:ext cx="7863840" cy="457200"/>
+          </a:xfrm>
+          <a:prstGeom prst="rect">
+            <a:avLst/>
+          </a:prstGeom>
+          <a:noFill/>
+        </p:spPr>
+        <p:txBody>
+          <a:bodyPr wrap="none">
+            <a:spAutoFit/>
+          </a:bodyPr>
+          <a:lstStyle/>
+          <a:p>
+            <a:r>
+              <a:t>Safe Failure Mode</a:t>
+            </a:r>
+          </a:p>
+        </p:txBody>
+      </p:sp>
+      <p:sp>
+        <p:nvSpPr>
+          <p:cNvPr id="10" name="TextBox 9"/>
+          <p:cNvSpPr txBox="1"/>
+          <p:nvPr/>
+        </p:nvSpPr>
+        <p:spPr>
+          <a:xfrm>
+            <a:off x="868680" y="5650992"/>
+            <a:ext cx="7498079" cy="822959"/>
+          </a:xfrm>
+          <a:prstGeom prst="rect">
+            <a:avLst/>
+          </a:prstGeom>
+          <a:noFill/>
+        </p:spPr>
+        <p:txBody>
+          <a:bodyPr wrap="square">
+            <a:spAutoFit/>
+          </a:bodyPr>
+          <a:lstStyle/>
+          <a:p>
+            <a:r>
+              <a:t>• When evidence is absent, system returns “not found in documents”</a:t>
             </a:r>
           </a:p>
         </p:txBody>
@@ -5093,60 +5199,44 @@
         <p:txBody>
           <a:bodyPr/>
           <a:lstStyle/>
-          <a:p/>
-          <a:p>
-            <a:pPr>
-              <a:spcAft>
-                <a:spcPts val="1200"/>
-              </a:spcAft>
+          <a:p>
+            <a:pPr>
               <a:defRPr sz="1800"/>
             </a:pPr>
             <a:r>
-              <a:t>🏛️ University Data Isolation — each university has separate database</a:t>
-            </a:r>
-          </a:p>
-          <a:p>
-            <a:pPr>
-              <a:spcAft>
-                <a:spcPts val="1200"/>
-              </a:spcAft>
+              <a:t>Institution-controlled deployment: core data remains on university infrastructure</a:t>
+            </a:r>
+          </a:p>
+          <a:p>
+            <a:pPr>
               <a:defRPr sz="1800"/>
             </a:pPr>
             <a:r>
-              <a:t>🔐 Role-Based Access — Professor vs Student permissions</a:t>
-            </a:r>
-          </a:p>
-          <a:p>
-            <a:pPr>
-              <a:spcAft>
-                <a:spcPts val="1200"/>
-              </a:spcAft>
+              <a:t>University/course-scoped collections enforce tenant isolation</a:t>
+            </a:r>
+          </a:p>
+          <a:p>
+            <a:pPr>
               <a:defRPr sz="1800"/>
             </a:pPr>
             <a:r>
-              <a:t>💻 Runs on YOUR server — no data sent to OpenAI/cloud</a:t>
-            </a:r>
-          </a:p>
-          <a:p>
-            <a:pPr>
-              <a:spcAft>
-                <a:spcPts val="1200"/>
-              </a:spcAft>
+              <a:t>Role-based workflow supports faculty governance of uploaded content</a:t>
+            </a:r>
+          </a:p>
+          <a:p>
+            <a:pPr>
               <a:defRPr sz="1800"/>
             </a:pPr>
             <a:r>
-              <a:t>📜 GDPR/FERPA compliant architecture</a:t>
-            </a:r>
-          </a:p>
-          <a:p>
-            <a:pPr>
-              <a:spcAft>
-                <a:spcPts val="1200"/>
-              </a:spcAft>
+              <a:t>Citation-first responses improve auditability and integrity reviews</a:t>
+            </a:r>
+          </a:p>
+          <a:p>
+            <a:pPr>
               <a:defRPr sz="1800"/>
             </a:pPr>
             <a:r>
-              <a:t>✅ All answers cite source documents for verification</a:t>
+              <a:t>Deletion path removes documents from both storage and retrieval index</a:t>
             </a:r>
           </a:p>
         </p:txBody>
@@ -5225,72 +5315,34 @@
             <a:spAutoFit/>
           </a:bodyPr>
           <a:lstStyle/>
-          <a:p/>
-          <a:p>
-            <a:pPr>
-              <a:defRPr sz="2000" b="1">
-                <a:solidFill>
-                  <a:srgbClr val="43E97B"/>
-                </a:solidFill>
-              </a:defRPr>
-            </a:pPr>
+          <a:p>
             <a:r>
               <a:t>Backend</a:t>
             </a:r>
           </a:p>
           <a:p>
-            <a:pPr>
-              <a:spcAft>
-                <a:spcPts val="800"/>
-              </a:spcAft>
-              <a:defRPr sz="1400"/>
-            </a:pPr>
-            <a:r>
-              <a:t>• Django 5.0 (Python framework)</a:t>
-            </a:r>
-          </a:p>
-          <a:p>
-            <a:pPr>
-              <a:spcAft>
-                <a:spcPts val="800"/>
-              </a:spcAft>
-              <a:defRPr sz="1400"/>
-            </a:pPr>
-            <a:r>
-              <a:t>• PostgreSQL database</a:t>
-            </a:r>
-          </a:p>
-          <a:p>
-            <a:pPr>
-              <a:spcAft>
-                <a:spcPts val="800"/>
-              </a:spcAft>
-              <a:defRPr sz="1400"/>
-            </a:pPr>
-            <a:r>
-              <a:t>• ChromaDB vector store</a:t>
-            </a:r>
-          </a:p>
-          <a:p>
-            <a:pPr>
-              <a:spcAft>
-                <a:spcPts val="800"/>
-              </a:spcAft>
-              <a:defRPr sz="1400"/>
-            </a:pPr>
-            <a:r>
-              <a:t>• Ollama (llama3.2:3b — CPU optimized)</a:t>
-            </a:r>
-          </a:p>
-          <a:p>
-            <a:pPr>
-              <a:spcAft>
-                <a:spcPts val="800"/>
-              </a:spcAft>
-              <a:defRPr sz="1400"/>
-            </a:pPr>
-            <a:r>
-              <a:t>• Docker containerization</a:t>
+            <a:r>
+              <a:t>• Django REST APIs for documents, RAG, quizzes, flashcards</a:t>
+            </a:r>
+          </a:p>
+          <a:p>
+            <a:r>
+              <a:t>• PostgreSQL for users, content metadata, learning artifacts</a:t>
+            </a:r>
+          </a:p>
+          <a:p>
+            <a:r>
+              <a:t>• ChromaDB for semantic vector retrieval</a:t>
+            </a:r>
+          </a:p>
+          <a:p>
+            <a:r>
+              <a:t>• Ollama (`llama3.2:3b`) for local answer generation</a:t>
+            </a:r>
+          </a:p>
+          <a:p>
+            <a:r>
+              <a:t>• Configurable relevance + context limits via Django settings</a:t>
             </a:r>
           </a:p>
         </p:txBody>
@@ -5316,72 +5368,29 @@
             <a:spAutoFit/>
           </a:bodyPr>
           <a:lstStyle/>
-          <a:p/>
-          <a:p>
-            <a:pPr>
-              <a:defRPr sz="2000" b="1">
-                <a:solidFill>
-                  <a:srgbClr val="FF6584"/>
-                </a:solidFill>
-              </a:defRPr>
-            </a:pPr>
+          <a:p>
             <a:r>
               <a:t>Frontend</a:t>
             </a:r>
           </a:p>
           <a:p>
-            <a:pPr>
-              <a:spcAft>
-                <a:spcPts val="800"/>
-              </a:spcAft>
-              <a:defRPr sz="1400"/>
-            </a:pPr>
-            <a:r>
-              <a:t>• React.js interface</a:t>
-            </a:r>
-          </a:p>
-          <a:p>
-            <a:pPr>
-              <a:spcAft>
-                <a:spcPts val="800"/>
-              </a:spcAft>
-              <a:defRPr sz="1400"/>
-            </a:pPr>
-            <a:r>
-              <a:t>• Responsive design</a:t>
-            </a:r>
-          </a:p>
-          <a:p>
-            <a:pPr>
-              <a:spcAft>
-                <a:spcPts val="800"/>
-              </a:spcAft>
-              <a:defRPr sz="1400"/>
-            </a:pPr>
-            <a:r>
-              <a:t>• Real-time progress charts</a:t>
-            </a:r>
-          </a:p>
-          <a:p>
-            <a:pPr>
-              <a:spcAft>
-                <a:spcPts val="800"/>
-              </a:spcAft>
-              <a:defRPr sz="1400"/>
-            </a:pPr>
-            <a:r>
-              <a:t>• Dark theme UI</a:t>
-            </a:r>
-          </a:p>
-          <a:p>
-            <a:pPr>
-              <a:spcAft>
-                <a:spcPts val="800"/>
-              </a:spcAft>
-              <a:defRPr sz="1400"/>
-            </a:pPr>
-            <a:r>
-              <a:t>• Works on any browser</a:t>
+            <a:r>
+              <a:t>• React interface for Q&amp;A, flashcards, quiz workflows</a:t>
+            </a:r>
+          </a:p>
+          <a:p>
+            <a:r>
+              <a:t>• Role-aware UX for professor and student journeys</a:t>
+            </a:r>
+          </a:p>
+          <a:p>
+            <a:r>
+              <a:t>• Progress and analytics views for learning feedback</a:t>
+            </a:r>
+          </a:p>
+          <a:p>
+            <a:r>
+              <a:t>• Works in browser and connects to local Docker deployment</a:t>
             </a:r>
           </a:p>
         </p:txBody>

</xml_diff>